<commit_message>
Powerups: Speed up and slow down
</commit_message>
<xml_diff>
--- a/Tyler_Final_Presentation.pptx
+++ b/Tyler_Final_Presentation.pptx
@@ -11815,7 +11815,7 @@
         </p:nvSpPr>
         <p:spPr>
           <a:xfrm>
-            <a:off x="0" y="0"/>
+            <a:off x="0" y="201168"/>
             <a:ext cx="12191695" cy="6858000"/>
           </a:xfrm>
           <a:prstGeom prst="rect">
@@ -12114,7 +12114,7 @@
         </p:nvSpPr>
         <p:spPr>
           <a:xfrm>
-            <a:off x="685800" y="1463040"/>
+            <a:off x="685800" y="1471507"/>
             <a:ext cx="5760720" cy="4480560"/>
           </a:xfrm>
           <a:prstGeom prst="rect">
@@ -13636,41 +13636,6 @@
             <a:r>
               <a:rPr dirty="0"/>
               <a:t>7. Factory Level Design</a:t>
-            </a:r>
-          </a:p>
-        </p:txBody>
-      </p:sp>
-      <p:sp>
-        <p:nvSpPr>
-          <p:cNvPr id="8" name="TextBox 7"/>
-          <p:cNvSpPr txBox="1"/>
-          <p:nvPr/>
-        </p:nvSpPr>
-        <p:spPr>
-          <a:xfrm>
-            <a:off x="621792" y="960120"/>
-            <a:ext cx="10789920" cy="411480"/>
-          </a:xfrm>
-          <a:prstGeom prst="rect">
-            <a:avLst/>
-          </a:prstGeom>
-          <a:noFill/>
-        </p:spPr>
-        <p:txBody>
-          <a:bodyPr wrap="none">
-            <a:spAutoFit/>
-          </a:bodyPr>
-          <a:lstStyle/>
-          <a:p>
-            <a:pPr>
-              <a:defRPr sz="1250">
-                <a:solidFill>
-                  <a:srgbClr val="AEB8CC"/>
-                </a:solidFill>
-              </a:defRPr>
-            </a:pPr>
-            <a:r>
-              <a:t>Level layout is externalized to JSON instead of hard-coded into Game.cpp</a:t>
             </a:r>
           </a:p>
         </p:txBody>

</xml_diff>